<commit_message>
changed title and script on s15
</commit_message>
<xml_diff>
--- a/Slides/Module 07.3 Project Planning and Estimation.pptx
+++ b/Slides/Module 07.3 Project Planning and Estimation.pptx
@@ -173,6 +173,35 @@
 </p:presentation>
 </file>
 
+<file path=ppt/changesInfos/changesInfo1.xml><?xml version="1.0" encoding="utf-8"?>
+<pc:chgInfo xmlns:a="http://schemas.openxmlformats.org/drawingml/2006/main" xmlns:r="http://schemas.openxmlformats.org/officeDocument/2006/relationships" xmlns:ac="http://schemas.microsoft.com/office/drawing/2013/main/command" xmlns:pc="http://schemas.microsoft.com/office/powerpoint/2013/main/command">
+  <pc:docChgLst>
+    <pc:chgData name="Mitchell Wand" userId="de9b44c55c049659" providerId="LiveId" clId="{7A9D5940-B2CC-47DD-AF5E-71219F1A1E26}"/>
+    <pc:docChg chg="custSel modSld">
+      <pc:chgData name="Mitchell Wand" userId="de9b44c55c049659" providerId="LiveId" clId="{7A9D5940-B2CC-47DD-AF5E-71219F1A1E26}" dt="2026-09-28T16:37:15.369" v="405" actId="20577"/>
+      <pc:docMkLst>
+        <pc:docMk/>
+      </pc:docMkLst>
+      <pc:sldChg chg="modSp mod modNotesTx">
+        <pc:chgData name="Mitchell Wand" userId="de9b44c55c049659" providerId="LiveId" clId="{7A9D5940-B2CC-47DD-AF5E-71219F1A1E26}" dt="2026-09-28T16:37:15.369" v="405" actId="20577"/>
+        <pc:sldMkLst>
+          <pc:docMk/>
+          <pc:sldMk cId="1674378907" sldId="547"/>
+        </pc:sldMkLst>
+        <pc:spChg chg="mod">
+          <ac:chgData name="Mitchell Wand" userId="de9b44c55c049659" providerId="LiveId" clId="{7A9D5940-B2CC-47DD-AF5E-71219F1A1E26}" dt="2026-09-28T16:28:44.256" v="27" actId="20577"/>
+          <ac:spMkLst>
+            <pc:docMk/>
+            <pc:sldMk cId="1674378907" sldId="547"/>
+            <ac:spMk id="2" creationId="{F336DFD9-3C00-A649-90C2-995DA0254305}"/>
+          </ac:spMkLst>
+        </pc:spChg>
+      </pc:sldChg>
+    </pc:docChg>
+  </pc:docChgLst>
+</pc:chgInfo>
+</file>
+
 <file path=ppt/notesMasters/notesMaster1.xml><?xml version="1.0" encoding="utf-8"?>
 <p:notesMaster xmlns:a="http://schemas.openxmlformats.org/drawingml/2006/main" xmlns:r="http://schemas.openxmlformats.org/officeDocument/2006/relationships" xmlns:p="http://schemas.openxmlformats.org/presentationml/2006/main">
   <p:cSld>
@@ -255,7 +284,7 @@
           <a:p>
             <a:fld id="{7C7E5181-6CF5-45F7-A87A-E0E0B1FD7549}" type="datetimeFigureOut">
               <a:rPr lang="en-US" smtClean="0"/>
-              <a:t>9/26/2026</a:t>
+              <a:t>9/28/2026</a:t>
             </a:fld>
             <a:endParaRPr lang="en-US"/>
           </a:p>
@@ -1263,8 +1292,13 @@
           <a:p>
             <a:r>
               <a:rPr lang="en-US" dirty="0"/>
-              <a:t>Now that we have our sprint planned and the sprint backlogged defined, it’s time to start to actually do the work and complete the tasks. During the sprint, we have a recurring meeting called the Daily Scrum.</a:t>
-            </a:r>
+              <a:t>We talked earlier about decreasing risk by dividing the project into time-boxed iterations called “sprints”.  Here’s a diagram showing the typical workflow in a sprint.  The key is the daily scrum meeting, or stand-up. That’s where the knowledge </a:t>
+            </a:r>
+            <a:r>
+              <a:rPr lang="en-US"/>
+              <a:t>sharing happens.</a:t>
+            </a:r>
+            <a:endParaRPr lang="en-US" dirty="0"/>
           </a:p>
         </p:txBody>
       </p:sp>
@@ -3961,7 +3995,7 @@
           <a:p>
             <a:fld id="{5D2A64DE-480B-420F-9649-4F8E696E08E0}" type="datetime1">
               <a:rPr lang="en-US" smtClean="0"/>
-              <a:t>9/26/2026</a:t>
+              <a:t>9/28/2026</a:t>
             </a:fld>
             <a:endParaRPr lang="en-US"/>
           </a:p>
@@ -4285,7 +4319,7 @@
           <a:p>
             <a:fld id="{EA476A42-A091-4468-A075-64A31BE59948}" type="datetime1">
               <a:rPr lang="en-US" smtClean="0"/>
-              <a:t>9/26/2026</a:t>
+              <a:t>9/28/2026</a:t>
             </a:fld>
             <a:endParaRPr lang="en-US"/>
           </a:p>
@@ -4483,7 +4517,7 @@
           <a:p>
             <a:fld id="{0D3616D0-8311-4107-9726-6B805E7D05BA}" type="datetime1">
               <a:rPr lang="en-US" smtClean="0"/>
-              <a:t>9/26/2026</a:t>
+              <a:t>9/28/2026</a:t>
             </a:fld>
             <a:endParaRPr lang="en-US"/>
           </a:p>
@@ -4691,7 +4725,7 @@
           <a:p>
             <a:fld id="{3BC2557A-5C88-417A-A763-5AC779462A5F}" type="datetime1">
               <a:rPr lang="en-US" smtClean="0"/>
-              <a:t>9/26/2026</a:t>
+              <a:t>9/28/2026</a:t>
             </a:fld>
             <a:endParaRPr lang="en-US"/>
           </a:p>
@@ -5215,7 +5249,7 @@
           <a:p>
             <a:fld id="{07C7BFD4-467E-4EDE-93EA-052F5B39A4E5}" type="datetime1">
               <a:rPr lang="en-US" smtClean="0"/>
-              <a:t>9/26/2026</a:t>
+              <a:t>9/28/2026</a:t>
             </a:fld>
             <a:endParaRPr lang="en-US"/>
           </a:p>
@@ -5465,7 +5499,7 @@
           <a:p>
             <a:fld id="{07C7BFD4-467E-4EDE-93EA-052F5B39A4E5}" type="datetime1">
               <a:rPr lang="en-US" smtClean="0"/>
-              <a:t>9/26/2026</a:t>
+              <a:t>9/28/2026</a:t>
             </a:fld>
             <a:endParaRPr lang="en-US"/>
           </a:p>
@@ -5647,7 +5681,7 @@
           <a:p>
             <a:fld id="{109E55A0-C911-4F03-82FC-7E5926047D46}" type="datetime1">
               <a:rPr lang="en-US" smtClean="0"/>
-              <a:t>9/26/2026</a:t>
+              <a:t>9/28/2026</a:t>
             </a:fld>
             <a:endParaRPr lang="en-US"/>
           </a:p>
@@ -5960,7 +5994,7 @@
           <a:p>
             <a:fld id="{A533CBE2-D5BE-47AC-ADC2-9CDFC1D0CF90}" type="datetime1">
               <a:rPr lang="en-US" smtClean="0"/>
-              <a:t>9/26/2026</a:t>
+              <a:t>9/28/2026</a:t>
             </a:fld>
             <a:endParaRPr lang="en-US"/>
           </a:p>
@@ -6261,7 +6295,7 @@
           <a:p>
             <a:fld id="{39B7EDB1-CE74-4951-85A2-0B01C2128E28}" type="datetime1">
               <a:rPr lang="en-US" smtClean="0"/>
-              <a:t>9/26/2026</a:t>
+              <a:t>9/28/2026</a:t>
             </a:fld>
             <a:endParaRPr lang="en-US"/>
           </a:p>
@@ -6709,7 +6743,7 @@
           <a:p>
             <a:fld id="{2BC7EB92-A5C2-4807-A9DC-9EDE6CBFB241}" type="datetime1">
               <a:rPr lang="en-US" smtClean="0"/>
-              <a:t>9/26/2026</a:t>
+              <a:t>9/28/2026</a:t>
             </a:fld>
             <a:endParaRPr lang="en-US"/>
           </a:p>
@@ -6822,7 +6856,7 @@
           <a:p>
             <a:fld id="{2B7B7EE0-7771-4CD5-9B2B-3550753A54A1}" type="datetime1">
               <a:rPr lang="en-US" smtClean="0"/>
-              <a:t>9/26/2026</a:t>
+              <a:t>9/28/2026</a:t>
             </a:fld>
             <a:endParaRPr lang="en-US"/>
           </a:p>
@@ -7133,7 +7167,7 @@
           <a:p>
             <a:fld id="{F8B318B3-0E87-4416-A9B8-D891968C2727}" type="datetime1">
               <a:rPr lang="en-US" smtClean="0"/>
-              <a:t>9/26/2026</a:t>
+              <a:t>9/28/2026</a:t>
             </a:fld>
             <a:endParaRPr lang="en-US"/>
           </a:p>
@@ -7374,7 +7408,7 @@
           <a:p>
             <a:fld id="{54D997E8-DDEE-43F1-8D9B-F8A1E11DE488}" type="datetime1">
               <a:rPr lang="en-US" smtClean="0"/>
-              <a:t>9/26/2026</a:t>
+              <a:t>9/28/2026</a:t>
             </a:fld>
             <a:endParaRPr lang="en-US"/>
           </a:p>
@@ -10101,7 +10135,7 @@
           <a:p>
             <a:r>
               <a:rPr lang="en-US" dirty="0"/>
-              <a:t>The Daily Scrum meeting is the key</a:t>
+              <a:t>Typical Sprint Process</a:t>
             </a:r>
           </a:p>
         </p:txBody>

</xml_diff>